<commit_message>
Pitch polish: 8-slide storytelling deck + re-voiced talk
- Added "how the kernel works" math beat (kernel = state overlap; bandwidth = the
  concentration knob) as deck slide 3, with concept diagram (make_concept.py)
- Rebuilt deck to 7-beat -> 8-beat arc; fixed image overflow (fit-to-box);
  synced speaker notes to the spoken beats
- Re-voiced PITCH_TALK.md into a conversational storytelling script, honest
  throughout (classical wins/ties, quantum slower, 0% safe auto-clear), with
  number guardrails and full Q&A

Co-Authored-By: Claude Opus 4.8 <noreply@anthropic.com>
</commit_message>
<xml_diff>
--- a/QSIEVE_pitch.pptx
+++ b/QSIEVE_pitch.pptx
@@ -12,6 +12,7 @@
     <p:sldId id="260" r:id="rId12"/>
     <p:sldId id="261" r:id="rId13"/>
     <p:sldId id="262" r:id="rId14"/>
+    <p:sldId id="263" r:id="rId15"/>
   </p:sldIdLst>
   <p:sldSz cx="12191695" cy="6858000" type="screen4x3"/>
   <p:notesSz cx="6858000" cy="9144000"/>
@@ -508,7 +509,7 @@
           <a:lstStyle/>
           <a:p>
             <a:r>
-              <a:t>[0:00-0:20] Most quantum pitches won't admit this: in 2026, on real data, a quantum kernel usually can't beat a well-tuned classical model. Most teams hide it. We made it our whole project — find out exactly how close quantum gets, and prove it on real hardware.</a:t>
+              <a:t>[0:00-0:30 HOOK] Let's be honest - everyone here already knows quantum can't beat tuned classical on real data today. So why are we here? Why not a Classical x Finance hackathon? People draw quantum as a curve crossing the classical line; on a problem like ours it bends the wrong way - more data, more expensive, no more accurate. That stuck place is our whole project: how close can quantum get, why was it losing, does the fix survive real hardware?</a:t>
             </a:r>
           </a:p>
         </p:txBody>
@@ -578,7 +579,7 @@
           <a:lstStyle/>
           <a:p>
             <a:r>
-              <a:t>[0:20-0:45] Our testbed is anti-money-laundering. Banks flag hundreds of thousands of accounts a year, 96% innocent, cleared by hand. We built a trust layer that auto-clears the confidently-innocent — and at its core is a quantum kernel asking how similar two accounts are. That's the product. The question we chased is: can that kernel actually compete?</a:t>
+              <a:t>[0:30-0:52 TESTBED] IBM AML data - 5M payments, ~388k flagged account-weeks, almost all innocent. The bank already flags; what it lacks is permission to REMOVE work. Our trust layer clears only when sure an account is clean - never accuses, logs every call. Quantum does one job: how similar are two account-weeks?</a:t>
             </a:r>
           </a:p>
         </p:txBody>
@@ -648,7 +649,7 @@
           <a:lstStyle/>
           <a:p>
             <a:r>
-              <a:t>[0:45-1:10] A fair fight — a properly tuned classical model vs the quantum kernel, identical data. Classical won, 0.19 to 0.12. We asked why, and tested everything: four encodings, eight scalings, kernel training, even a hybrid. All the same spot — quantum tying the classical kernel but losing to the tree. It looked stuck.</a:t>
+              <a:t>[0:52-1:14 MATH] 30 seconds on how it works. Each account becomes a quantum state; the kernel is how much two states overlap (identical = 1, opposite = 0). The catch, and it's our whole result: rotate too far and every account spreads to opposite corners, all look equally different - the kernel goes blind. How far you rotate is one number: the bandwidth. Hold that word.</a:t>
             </a:r>
           </a:p>
         </p:txBody>
@@ -718,7 +719,7 @@
           <a:lstStyle/>
           <a:p>
             <a:r>
-              <a:t>[1:10-1:45] The culprit was bandwidth. We encoded at the wrong scale — features rotated so far that every pair looked equally different; the kernel concentrated. Shrink the angles to a tenth and the score jumps 0.12 to 0.18 — level with the tuned tree. And because our mentor warned quantum tuning is 'mostly trial and error', we derived the optimum: one over root n-times-d, 0.083 — exactly the measured peak.</a:t>
+              <a:t>[1:14-1:34 BENCHMARK] Fair fight first: tuned tree 0.19, quantum 0.12 (random 0.09; beats RBF 0.097, loses to the tree). We asked why - four encodings, circuit training, a hybrid; 93 windows moved, the score didn't. Stuck.</a:t>
             </a:r>
           </a:p>
         </p:txBody>
@@ -788,7 +789,7 @@
           <a:lstStyle/>
           <a:p>
             <a:r>
-              <a:t>[1:45-2:25] A simulator number is cheap. So this weekend we put the tuned kernel on three real quantum computers — IBM, IQM, and VTT's Q50 — and did it properly: simulator, then noise models, then real metal, so we never burned credits on a guess. Averaged across all three, hardware matched simulator. On the robust config, drift was near zero — identical results on three different chips.</a:t>
+              <a:t>[1:34-2:06 BANDWIDTH] Found it: the bandwidth was wrong, the kernel blind. Shrink the angles to ~a tenth: 0.12 -&gt; 0.18, level with the tree (0.17). Error bars overlap = a TIE, not a win - say it plainly. And we DERIVED the scale, 1/sqrt(n*d) = 0.083, hitting the measured peak. No trial-and-error.</a:t>
             </a:r>
           </a:p>
         </p:txBody>
@@ -858,7 +859,7 @@
           <a:lstStyle/>
           <a:p>
             <a:r>
-              <a:t>[2:25-2:45] Show the dashboard. Ranked queue, auto-clear the confident cases, abstain on the rest, full audit log, and the live evaluation with the three-QPU panel.</a:t>
+              <a:t>[2:06-2:38 HARDWARE] A simulator tie is cheap. 3 real QPUs - IQM Garnet, IBM, VTT Q50 - sim, then noise model, then chip. Quiet 6-qubit config: Garnet &amp; IBM reproduce the sim exactly (0.111-&gt;0.111), Q50 moves one point. Tuned: the 3 chips average back onto the sim, 0.22 vs 0.23. Held on average, 3 vendors. Runs on real metal today.</a:t>
             </a:r>
           </a:p>
         </p:txBody>
@@ -928,7 +929,77 @@
           <a:lstStyle/>
           <a:p>
             <a:r>
-              <a:t>[2:45-3:00] We cannot claim quantum beats classical today, and anyone who does is selling you something. What we give you is the honest, hardware-validated map of how close it gets, why, and how to fix it — analytically, not by luck. Diagnose, derive, validate. That rigour is what we're proud of. Thank you.</a:t>
+              <a:t>[2:38-2:52 DEMO] All live: the ranked queue, the auto-clear, an audit line per decision, and the evaluation page with the three-machine table. Real data, real results.</a:t>
+            </a:r>
+          </a:p>
+        </p:txBody>
+      </p:sp>
+      <p:sp>
+        <p:nvSpPr>
+          <p:cNvPr id="4" name="Slide Number Placeholder 3"/>
+          <p:cNvSpPr>
+            <a:spLocks noGrp="1"/>
+          </p:cNvSpPr>
+          <p:nvPr>
+            <p:ph type="sldNum" idx="5" sz="quarter"/>
+          </p:nvPr>
+        </p:nvSpPr>
+        <p:spPr/>
+      </p:sp>
+    </p:spTree>
+  </p:cSld>
+  <p:clrMapOvr>
+    <a:masterClrMapping/>
+  </p:clrMapOvr>
+</p:notes>
+</file>
+
+<file path=ppt/notesSlides/notesSlide8.xml><?xml version="1.0" encoding="utf-8"?>
+<p:notes xmlns:a="http://schemas.openxmlformats.org/drawingml/2006/main" xmlns:p="http://schemas.openxmlformats.org/presentationml/2006/main" xmlns:r="http://schemas.openxmlformats.org/officeDocument/2006/relationships">
+  <p:cSld>
+    <p:spTree>
+      <p:nvGrpSpPr>
+        <p:cNvPr id="1" name=""/>
+        <p:cNvGrpSpPr/>
+        <p:nvPr/>
+      </p:nvGrpSpPr>
+      <p:grpSpPr>
+        <a:xfrm>
+          <a:off x="0" y="0"/>
+          <a:ext cx="0" cy="0"/>
+          <a:chOff x="0" y="0"/>
+          <a:chExt cx="0" cy="0"/>
+        </a:xfrm>
+      </p:grpSpPr>
+      <p:sp>
+        <p:nvSpPr>
+          <p:cNvPr id="2" name="Slide Image Placeholder 1"/>
+          <p:cNvSpPr>
+            <a:spLocks noGrp="1"/>
+          </p:cNvSpPr>
+          <p:nvPr>
+            <p:ph type="sldImg" idx="2"/>
+          </p:nvPr>
+        </p:nvSpPr>
+        <p:spPr/>
+      </p:sp>
+      <p:sp>
+        <p:nvSpPr>
+          <p:cNvPr id="3" name="Notes Placeholder 2"/>
+          <p:cNvSpPr>
+            <a:spLocks noGrp="1"/>
+          </p:cNvSpPr>
+          <p:nvPr>
+            <p:ph type="body" idx="3" sz="quarter"/>
+          </p:nvPr>
+        </p:nvSpPr>
+        <p:spPr/>
+        <p:txBody>
+          <a:bodyPr/>
+          <a:lstStyle/>
+          <a:p>
+            <a:r>
+              <a:t>[2:52-3:10 CLOSE] What we WON'T claim: it doesn't empty the queue (safe threshold clears 0), and the tree is faster (0.1s vs 18s) - say it before they ask. The honest map is the contribution: why it was stuck, the derived fix, 3 real machines. The curve hasn't crossed the line - but we found the line and know which way it moves. Diagnose, derive, validate. Team Q-SIEVE. Thank you.</a:t>
             </a:r>
           </a:p>
         </p:txBody>
@@ -4213,7 +4284,7 @@
         </p:nvSpPr>
         <p:spPr>
           <a:xfrm>
-            <a:off x="640080" y="502920"/>
+            <a:off x="640080" y="475488"/>
             <a:ext cx="1280160" cy="63500"/>
           </a:xfrm>
           <a:prstGeom prst="rect">
@@ -4257,7 +4328,7 @@
         </p:nvSpPr>
         <p:spPr>
           <a:xfrm>
-            <a:off x="640080" y="658368"/>
+            <a:off x="640080" y="621792"/>
             <a:ext cx="10972800" cy="822960"/>
           </a:xfrm>
           <a:prstGeom prst="rect">
@@ -4277,7 +4348,7 @@
               </a:spcAft>
             </a:pPr>
             <a:r>
-              <a:rPr sz="3400" b="1" i="0">
+              <a:rPr sz="3200" b="1" i="0">
                 <a:solidFill>
                   <a:srgbClr val="FFFFFF"/>
                 </a:solidFill>
@@ -4335,7 +4406,7 @@
         </p:nvSpPr>
         <p:spPr>
           <a:xfrm>
-            <a:off x="640080" y="1554480"/>
+            <a:off x="640080" y="1508760"/>
             <a:ext cx="10972800" cy="1371600"/>
           </a:xfrm>
           <a:prstGeom prst="rect">
@@ -4355,7 +4426,7 @@
               </a:spcAft>
             </a:pPr>
             <a:r>
-              <a:rPr sz="2400" b="1" i="0">
+              <a:rPr sz="2300" b="1" i="0">
                 <a:solidFill>
                   <a:srgbClr val="67E1C5"/>
                 </a:solidFill>
@@ -4390,7 +4461,7 @@
         </p:nvSpPr>
         <p:spPr>
           <a:xfrm>
-            <a:off x="640080" y="3291840"/>
+            <a:off x="640080" y="3200400"/>
             <a:ext cx="3566160" cy="2468880"/>
           </a:xfrm>
           <a:prstGeom prst="rect">
@@ -4481,7 +4552,7 @@
         </p:nvSpPr>
         <p:spPr>
           <a:xfrm>
-            <a:off x="4434840" y="3291840"/>
+            <a:off x="4434840" y="3200400"/>
             <a:ext cx="3566160" cy="2468880"/>
           </a:xfrm>
           <a:prstGeom prst="rect">
@@ -4572,7 +4643,7 @@
         </p:nvSpPr>
         <p:spPr>
           <a:xfrm>
-            <a:off x="8229600" y="3291840"/>
+            <a:off x="8229600" y="3200400"/>
             <a:ext cx="3566160" cy="2468880"/>
           </a:xfrm>
           <a:prstGeom prst="rect">
@@ -4725,7 +4796,7 @@
         </p:nvSpPr>
         <p:spPr>
           <a:xfrm>
-            <a:off x="640080" y="502920"/>
+            <a:off x="640080" y="475488"/>
             <a:ext cx="1280160" cy="63500"/>
           </a:xfrm>
           <a:prstGeom prst="rect">
@@ -4769,7 +4840,7 @@
         </p:nvSpPr>
         <p:spPr>
           <a:xfrm>
-            <a:off x="640080" y="658368"/>
+            <a:off x="640080" y="621792"/>
             <a:ext cx="10972800" cy="822960"/>
           </a:xfrm>
           <a:prstGeom prst="rect">
@@ -4789,13 +4860,13 @@
               </a:spcAft>
             </a:pPr>
             <a:r>
-              <a:rPr sz="3400" b="1" i="0">
+              <a:rPr sz="3200" b="1" i="0">
                 <a:solidFill>
                   <a:srgbClr val="FFFFFF"/>
                 </a:solidFill>
                 <a:latin typeface="Segoe UI"/>
               </a:rPr>
-              <a:t>We ran a fair fight — classical won. At first.</a:t>
+              <a:t>How the kernel works — and the one knob that matters</a:t>
             </a:r>
           </a:p>
         </p:txBody>
@@ -4834,14 +4905,14 @@
                 </a:solidFill>
                 <a:latin typeface="Segoe UI"/>
               </a:rPr>
-              <a:t>METHODOLOGY</a:t>
+              <a:t>THE MECHANISM</a:t>
             </a:r>
           </a:p>
         </p:txBody>
       </p:sp>
       <p:pic>
         <p:nvPicPr>
-          <p:cNvPr id="6" name="Picture 5" descr="01_benchmark.png"/>
+          <p:cNvPr id="6" name="Picture 5" descr="05_kernel_concept.png"/>
           <p:cNvPicPr>
             <a:picLocks noChangeAspect="1"/>
           </p:cNvPicPr>
@@ -4855,8 +4926,8 @@
         </p:blipFill>
         <p:spPr>
           <a:xfrm>
-            <a:off x="1188720" y="1554480"/>
-            <a:ext cx="6949440" cy="4108704"/>
+            <a:off x="1981016" y="1371600"/>
+            <a:ext cx="8290927" cy="4480560"/>
           </a:xfrm>
           <a:prstGeom prst="rect">
             <a:avLst/>
@@ -4871,8 +4942,8 @@
         </p:nvSpPr>
         <p:spPr>
           <a:xfrm>
-            <a:off x="8321040" y="1828800"/>
-            <a:ext cx="3291840" cy="4114800"/>
+            <a:off x="640080" y="5943600"/>
+            <a:ext cx="10972800" cy="731520"/>
           </a:xfrm>
           <a:prstGeom prst="rect">
             <a:avLst/>
@@ -4880,26 +4951,10 @@
           <a:noFill/>
         </p:spPr>
         <p:txBody>
-          <a:bodyPr wrap="square" anchor="ctr">
+          <a:bodyPr wrap="square" anchor="t">
             <a:spAutoFit/>
           </a:bodyPr>
           <a:lstStyle/>
-          <a:p>
-            <a:pPr algn="l">
-              <a:spcAft>
-                <a:spcPts val="1000"/>
-              </a:spcAft>
-            </a:pPr>
-            <a:r>
-              <a:rPr sz="1700" b="1" i="0">
-                <a:solidFill>
-                  <a:srgbClr val="FFFFFF"/>
-                </a:solidFill>
-                <a:latin typeface="Segoe UI"/>
-              </a:rPr>
-              <a:t>Tuned classical vs quantum, identical data.</a:t>
-            </a:r>
-          </a:p>
           <a:p>
             <a:pPr algn="l">
               <a:spcAft>
@@ -4907,61 +4962,13 @@
               </a:spcAft>
             </a:pPr>
             <a:r>
-              <a:rPr sz="1600" b="0" i="0">
+              <a:rPr sz="1600" b="1" i="0">
                 <a:solidFill>
-                  <a:srgbClr val="ADC5C7"/>
+                  <a:srgbClr val="67E1C5"/>
                 </a:solidFill>
                 <a:latin typeface="Segoe UI"/>
               </a:rPr>
-              <a:t>•  XGBoost 0.19 beat quantum 0.125.</a:t>
-            </a:r>
-          </a:p>
-          <a:p>
-            <a:pPr algn="l">
-              <a:spcAft>
-                <a:spcPts val="800"/>
-              </a:spcAft>
-            </a:pPr>
-            <a:r>
-              <a:rPr sz="1600" b="0" i="0">
-                <a:solidFill>
-                  <a:srgbClr val="ADC5C7"/>
-                </a:solidFill>
-                <a:latin typeface="Segoe UI"/>
-              </a:rPr>
-              <a:t>•  We could have spun it. Instead we asked WHY —</a:t>
-            </a:r>
-          </a:p>
-          <a:p>
-            <a:pPr algn="l">
-              <a:spcAft>
-                <a:spcPts val="800"/>
-              </a:spcAft>
-            </a:pPr>
-            <a:r>
-              <a:rPr sz="1600" b="0" i="0">
-                <a:solidFill>
-                  <a:srgbClr val="ADC5C7"/>
-                </a:solidFill>
-                <a:latin typeface="Segoe UI"/>
-              </a:rPr>
-              <a:t>•  and tested 4 encodings, 8 scalings, kernel training, a hybrid.</a:t>
-            </a:r>
-          </a:p>
-          <a:p>
-            <a:pPr algn="l">
-              <a:spcAft>
-                <a:spcPts val="800"/>
-              </a:spcAft>
-            </a:pPr>
-            <a:r>
-              <a:rPr sz="1600" b="1" i="0">
-                <a:solidFill>
-                  <a:srgbClr val="E6B74D"/>
-                </a:solidFill>
-                <a:latin typeface="Segoe UI"/>
-              </a:rPr>
-              <a:t>•  Everything landed in the same spot. Quantum looked stuck.</a:t>
+              <a:t>Similarity = overlap of two account-states.  “Bandwidth” = how far we rotate the data — and it decides whether the kernel can see at all.  Hold that thought.</a:t>
             </a:r>
           </a:p>
         </p:txBody>
@@ -5036,7 +5043,7 @@
         </p:nvSpPr>
         <p:spPr>
           <a:xfrm>
-            <a:off x="640080" y="502920"/>
+            <a:off x="640080" y="475488"/>
             <a:ext cx="1280160" cy="63500"/>
           </a:xfrm>
           <a:prstGeom prst="rect">
@@ -5080,7 +5087,7 @@
         </p:nvSpPr>
         <p:spPr>
           <a:xfrm>
-            <a:off x="640080" y="658368"/>
+            <a:off x="640080" y="621792"/>
             <a:ext cx="10972800" cy="822960"/>
           </a:xfrm>
           <a:prstGeom prst="rect">
@@ -5100,13 +5107,13 @@
               </a:spcAft>
             </a:pPr>
             <a:r>
-              <a:rPr sz="3400" b="1" i="0">
+              <a:rPr sz="3200" b="1" i="0">
                 <a:solidFill>
                   <a:srgbClr val="FFFFFF"/>
                 </a:solidFill>
                 <a:latin typeface="Segoe UI"/>
               </a:rPr>
-              <a:t>The culprit: bandwidth — and we derived it</a:t>
+              <a:t>We ran a fair fight — classical won. At first.</a:t>
             </a:r>
           </a:p>
         </p:txBody>
@@ -5145,14 +5152,14 @@
                 </a:solidFill>
                 <a:latin typeface="Segoe UI"/>
               </a:rPr>
-              <a:t>INNOVATIVENESS</a:t>
+              <a:t>METHODOLOGY</a:t>
             </a:r>
           </a:p>
         </p:txBody>
       </p:sp>
       <p:pic>
         <p:nvPicPr>
-          <p:cNvPr id="6" name="Picture 5" descr="02_bandwidth.png"/>
+          <p:cNvPr id="6" name="Picture 5" descr="01_benchmark.png"/>
           <p:cNvPicPr>
             <a:picLocks noChangeAspect="1"/>
           </p:cNvPicPr>
@@ -5166,8 +5173,8 @@
         </p:blipFill>
         <p:spPr>
           <a:xfrm>
-            <a:off x="1188720" y="1554480"/>
-            <a:ext cx="7223760" cy="3987103"/>
+            <a:off x="640080" y="1495124"/>
+            <a:ext cx="7315200" cy="4324952"/>
           </a:xfrm>
           <a:prstGeom prst="rect">
             <a:avLst/>
@@ -5182,8 +5189,8 @@
         </p:nvSpPr>
         <p:spPr>
           <a:xfrm>
-            <a:off x="8595360" y="1828800"/>
-            <a:ext cx="3108960" cy="4114800"/>
+            <a:off x="8229600" y="1737360"/>
+            <a:ext cx="3474720" cy="4206240"/>
           </a:xfrm>
           <a:prstGeom prst="rect">
             <a:avLst/>
@@ -5208,7 +5215,7 @@
                 </a:solidFill>
                 <a:latin typeface="Segoe UI"/>
               </a:rPr>
-              <a:t>Wrong scale → the kernel “concentrated” and lost signal.</a:t>
+              <a:t>Tuned classical vs quantum, identical data.</a:t>
             </a:r>
           </a:p>
           <a:p>
@@ -5218,13 +5225,13 @@
               </a:spcAft>
             </a:pPr>
             <a:r>
-              <a:rPr sz="1600" b="1" i="0">
+              <a:rPr sz="1500" b="0" i="0">
                 <a:solidFill>
-                  <a:srgbClr val="67E1C5"/>
+                  <a:srgbClr val="ADC5C7"/>
                 </a:solidFill>
                 <a:latin typeface="Segoe UI"/>
               </a:rPr>
-              <a:t>•  Shrink the angles → 0.125 → 0.18.</a:t>
+              <a:t>•  XGBoost 0.19 beat quantum 0.125.</a:t>
             </a:r>
           </a:p>
           <a:p>
@@ -5234,13 +5241,13 @@
               </a:spcAft>
             </a:pPr>
             <a:r>
-              <a:rPr sz="1600" b="0" i="0">
+              <a:rPr sz="1500" b="0" i="0">
                 <a:solidFill>
                   <a:srgbClr val="ADC5C7"/>
                 </a:solidFill>
                 <a:latin typeface="Segoe UI"/>
               </a:rPr>
-              <a:t>•  Level with the tuned classical tree.</a:t>
+              <a:t>•  We could have spun it. We asked WHY —</a:t>
             </a:r>
           </a:p>
           <a:p>
@@ -5250,13 +5257,13 @@
               </a:spcAft>
             </a:pPr>
             <a:r>
-              <a:rPr sz="1600" b="0" i="0">
+              <a:rPr sz="1500" b="0" i="0">
                 <a:solidFill>
                   <a:srgbClr val="ADC5C7"/>
                 </a:solidFill>
                 <a:latin typeface="Segoe UI"/>
               </a:rPr>
-              <a:t>•  No trial-and-error: we derived it, c = 1/√(n·d) = 0.083 —</a:t>
+              <a:t>•  and tested 4 encodings, 8 scalings, training, a hybrid.</a:t>
             </a:r>
           </a:p>
           <a:p>
@@ -5266,13 +5273,13 @@
               </a:spcAft>
             </a:pPr>
             <a:r>
-              <a:rPr sz="1600" b="1" i="0">
+              <a:rPr sz="1500" b="1" i="0">
                 <a:solidFill>
                   <a:srgbClr val="E6B74D"/>
                 </a:solidFill>
                 <a:latin typeface="Segoe UI"/>
               </a:rPr>
-              <a:t>•  which landed exactly on the measured peak.</a:t>
+              <a:t>•  All the same spot. Quantum looked stuck.</a:t>
             </a:r>
           </a:p>
         </p:txBody>
@@ -5347,7 +5354,7 @@
         </p:nvSpPr>
         <p:spPr>
           <a:xfrm>
-            <a:off x="640080" y="502920"/>
+            <a:off x="640080" y="475488"/>
             <a:ext cx="1280160" cy="63500"/>
           </a:xfrm>
           <a:prstGeom prst="rect">
@@ -5391,7 +5398,7 @@
         </p:nvSpPr>
         <p:spPr>
           <a:xfrm>
-            <a:off x="640080" y="658368"/>
+            <a:off x="640080" y="621792"/>
             <a:ext cx="10972800" cy="822960"/>
           </a:xfrm>
           <a:prstGeom prst="rect">
@@ -5411,13 +5418,13 @@
               </a:spcAft>
             </a:pPr>
             <a:r>
-              <a:rPr sz="3400" b="1" i="0">
+              <a:rPr sz="3200" b="1" i="0">
                 <a:solidFill>
                   <a:srgbClr val="FFFFFF"/>
                 </a:solidFill>
                 <a:latin typeface="Segoe UI"/>
               </a:rPr>
-              <a:t>Then we proved it on three real quantum computers</a:t>
+              <a:t>The culprit: bandwidth — and we derived it</a:t>
             </a:r>
           </a:p>
         </p:txBody>
@@ -5456,14 +5463,14 @@
                 </a:solidFill>
                 <a:latin typeface="Segoe UI"/>
               </a:rPr>
-              <a:t>METHODOLOGY · PROGRESS</a:t>
+              <a:t>INNOVATIVENESS</a:t>
             </a:r>
           </a:p>
         </p:txBody>
       </p:sp>
       <p:pic>
         <p:nvPicPr>
-          <p:cNvPr id="6" name="Picture 5" descr="03_hardware_tuned.png"/>
+          <p:cNvPr id="6" name="Picture 5" descr="02_bandwidth.png"/>
           <p:cNvPicPr>
             <a:picLocks noChangeAspect="1"/>
           </p:cNvPicPr>
@@ -5477,48 +5484,24 @@
         </p:blipFill>
         <p:spPr>
           <a:xfrm>
-            <a:off x="457200" y="1600200"/>
-            <a:ext cx="5943600" cy="3029348"/>
+            <a:off x="640080" y="1588343"/>
+            <a:ext cx="7498079" cy="4138511"/>
           </a:xfrm>
           <a:prstGeom prst="rect">
             <a:avLst/>
           </a:prstGeom>
         </p:spPr>
       </p:pic>
-      <p:pic>
-        <p:nvPicPr>
-          <p:cNvPr id="7" name="Picture 6" descr="04_hardware_robust.png"/>
-          <p:cNvPicPr>
-            <a:picLocks noChangeAspect="1"/>
-          </p:cNvPicPr>
-          <p:nvPr/>
-        </p:nvPicPr>
-        <p:blipFill>
-          <a:blip r:embed="rId3"/>
-          <a:stretch>
-            <a:fillRect/>
-          </a:stretch>
-        </p:blipFill>
-        <p:spPr>
-          <a:xfrm>
-            <a:off x="6492240" y="1600200"/>
-            <a:ext cx="5943600" cy="3169253"/>
-          </a:xfrm>
-          <a:prstGeom prst="rect">
-            <a:avLst/>
-          </a:prstGeom>
-        </p:spPr>
-      </p:pic>
-      <p:sp>
-        <p:nvSpPr>
-          <p:cNvPr id="8" name="TextBox 7"/>
+      <p:sp>
+        <p:nvSpPr>
+          <p:cNvPr id="7" name="TextBox 6"/>
           <p:cNvSpPr txBox="1"/>
           <p:nvPr/>
         </p:nvSpPr>
         <p:spPr>
           <a:xfrm>
-            <a:off x="640080" y="5806440"/>
-            <a:ext cx="10972800" cy="822960"/>
+            <a:off x="8412480" y="1737360"/>
+            <a:ext cx="3291840" cy="4206240"/>
           </a:xfrm>
           <a:prstGeom prst="rect">
             <a:avLst/>
@@ -5526,10 +5509,26 @@
           <a:noFill/>
         </p:spPr>
         <p:txBody>
-          <a:bodyPr wrap="square" anchor="t">
+          <a:bodyPr wrap="square" anchor="ctr">
             <a:spAutoFit/>
           </a:bodyPr>
           <a:lstStyle/>
+          <a:p>
+            <a:pPr algn="l">
+              <a:spcAft>
+                <a:spcPts val="1000"/>
+              </a:spcAft>
+            </a:pPr>
+            <a:r>
+              <a:rPr sz="1700" b="1" i="0">
+                <a:solidFill>
+                  <a:srgbClr val="FFFFFF"/>
+                </a:solidFill>
+                <a:latin typeface="Segoe UI"/>
+              </a:rPr>
+              <a:t>Wrong scale → the kernel “concentrated”, lost signal.</a:t>
+            </a:r>
+          </a:p>
           <a:p>
             <a:pPr algn="l">
               <a:spcAft>
@@ -5537,13 +5536,61 @@
               </a:spcAft>
             </a:pPr>
             <a:r>
-              <a:rPr sz="1600" b="1" i="0">
+              <a:rPr sz="1500" b="1" i="0">
                 <a:solidFill>
                   <a:srgbClr val="67E1C5"/>
                 </a:solidFill>
                 <a:latin typeface="Segoe UI"/>
               </a:rPr>
-              <a:t>Disciplined sim → noise-model → real metal. Tuned kernel held on average across IBM, IQM, VTT. Robust config: near-zero drift on all three vendors.</a:t>
+              <a:t>•  Shrink the angles → 0.125 → 0.18.</a:t>
+            </a:r>
+          </a:p>
+          <a:p>
+            <a:pPr algn="l">
+              <a:spcAft>
+                <a:spcPts val="800"/>
+              </a:spcAft>
+            </a:pPr>
+            <a:r>
+              <a:rPr sz="1500" b="0" i="0">
+                <a:solidFill>
+                  <a:srgbClr val="ADC5C7"/>
+                </a:solidFill>
+                <a:latin typeface="Segoe UI"/>
+              </a:rPr>
+              <a:t>•  Level with the tuned classical tree.</a:t>
+            </a:r>
+          </a:p>
+          <a:p>
+            <a:pPr algn="l">
+              <a:spcAft>
+                <a:spcPts val="800"/>
+              </a:spcAft>
+            </a:pPr>
+            <a:r>
+              <a:rPr sz="1500" b="0" i="0">
+                <a:solidFill>
+                  <a:srgbClr val="ADC5C7"/>
+                </a:solidFill>
+                <a:latin typeface="Segoe UI"/>
+              </a:rPr>
+              <a:t>•  No trial-and-error — derived: c = 1/√(n·d) = 0.083,</a:t>
+            </a:r>
+          </a:p>
+          <a:p>
+            <a:pPr algn="l">
+              <a:spcAft>
+                <a:spcPts val="800"/>
+              </a:spcAft>
+            </a:pPr>
+            <a:r>
+              <a:rPr sz="1500" b="1" i="0">
+                <a:solidFill>
+                  <a:srgbClr val="E6B74D"/>
+                </a:solidFill>
+                <a:latin typeface="Segoe UI"/>
+              </a:rPr>
+              <a:t>•  landing exactly on the measured peak.</a:t>
             </a:r>
           </a:p>
         </p:txBody>
@@ -5618,7 +5665,7 @@
         </p:nvSpPr>
         <p:spPr>
           <a:xfrm>
-            <a:off x="640080" y="502920"/>
+            <a:off x="640080" y="475488"/>
             <a:ext cx="1280160" cy="63500"/>
           </a:xfrm>
           <a:prstGeom prst="rect">
@@ -5662,7 +5709,7 @@
         </p:nvSpPr>
         <p:spPr>
           <a:xfrm>
-            <a:off x="640080" y="658368"/>
+            <a:off x="640080" y="621792"/>
             <a:ext cx="10972800" cy="822960"/>
           </a:xfrm>
           <a:prstGeom prst="rect">
@@ -5682,7 +5729,278 @@
               </a:spcAft>
             </a:pPr>
             <a:r>
-              <a:rPr sz="3400" b="1" i="0">
+              <a:rPr sz="3200" b="1" i="0">
+                <a:solidFill>
+                  <a:srgbClr val="FFFFFF"/>
+                </a:solidFill>
+                <a:latin typeface="Segoe UI"/>
+              </a:rPr>
+              <a:t>Then we proved it on three real quantum computers</a:t>
+            </a:r>
+          </a:p>
+        </p:txBody>
+      </p:sp>
+      <p:sp>
+        <p:nvSpPr>
+          <p:cNvPr id="5" name="TextBox 4"/>
+          <p:cNvSpPr txBox="1"/>
+          <p:nvPr/>
+        </p:nvSpPr>
+        <p:spPr>
+          <a:xfrm>
+            <a:off x="8321040" y="457200"/>
+            <a:ext cx="3200400" cy="365760"/>
+          </a:xfrm>
+          <a:prstGeom prst="rect">
+            <a:avLst/>
+          </a:prstGeom>
+          <a:noFill/>
+        </p:spPr>
+        <p:txBody>
+          <a:bodyPr wrap="square" anchor="t">
+            <a:spAutoFit/>
+          </a:bodyPr>
+          <a:lstStyle/>
+          <a:p>
+            <a:pPr algn="r">
+              <a:spcAft>
+                <a:spcPts val="800"/>
+              </a:spcAft>
+            </a:pPr>
+            <a:r>
+              <a:rPr sz="1200" b="1" i="0">
+                <a:solidFill>
+                  <a:srgbClr val="67E1C5"/>
+                </a:solidFill>
+                <a:latin typeface="Segoe UI"/>
+              </a:rPr>
+              <a:t>METHODOLOGY · PROGRESS</a:t>
+            </a:r>
+          </a:p>
+        </p:txBody>
+      </p:sp>
+      <p:pic>
+        <p:nvPicPr>
+          <p:cNvPr id="6" name="Picture 5" descr="03_hardware_tuned.png"/>
+          <p:cNvPicPr>
+            <a:picLocks noChangeAspect="1"/>
+          </p:cNvPicPr>
+          <p:nvPr/>
+        </p:nvPicPr>
+        <p:blipFill>
+          <a:blip r:embed="rId2"/>
+          <a:stretch>
+            <a:fillRect/>
+          </a:stretch>
+        </p:blipFill>
+        <p:spPr>
+          <a:xfrm>
+            <a:off x="457200" y="2053256"/>
+            <a:ext cx="5577840" cy="2842927"/>
+          </a:xfrm>
+          <a:prstGeom prst="rect">
+            <a:avLst/>
+          </a:prstGeom>
+        </p:spPr>
+      </p:pic>
+      <p:pic>
+        <p:nvPicPr>
+          <p:cNvPr id="7" name="Picture 6" descr="04_hardware_robust.png"/>
+          <p:cNvPicPr>
+            <a:picLocks noChangeAspect="1"/>
+          </p:cNvPicPr>
+          <p:nvPr/>
+        </p:nvPicPr>
+        <p:blipFill>
+          <a:blip r:embed="rId3"/>
+          <a:stretch>
+            <a:fillRect/>
+          </a:stretch>
+        </p:blipFill>
+        <p:spPr>
+          <a:xfrm>
+            <a:off x="6153912" y="1987608"/>
+            <a:ext cx="5577840" cy="2974223"/>
+          </a:xfrm>
+          <a:prstGeom prst="rect">
+            <a:avLst/>
+          </a:prstGeom>
+        </p:spPr>
+      </p:pic>
+      <p:sp>
+        <p:nvSpPr>
+          <p:cNvPr id="8" name="TextBox 7"/>
+          <p:cNvSpPr txBox="1"/>
+          <p:nvPr/>
+        </p:nvSpPr>
+        <p:spPr>
+          <a:xfrm>
+            <a:off x="640080" y="5715000"/>
+            <a:ext cx="10972800" cy="914400"/>
+          </a:xfrm>
+          <a:prstGeom prst="rect">
+            <a:avLst/>
+          </a:prstGeom>
+          <a:noFill/>
+        </p:spPr>
+        <p:txBody>
+          <a:bodyPr wrap="square" anchor="t">
+            <a:spAutoFit/>
+          </a:bodyPr>
+          <a:lstStyle/>
+          <a:p>
+            <a:pPr algn="l">
+              <a:spcAft>
+                <a:spcPts val="800"/>
+              </a:spcAft>
+            </a:pPr>
+            <a:r>
+              <a:rPr sz="1600" b="1" i="0">
+                <a:solidFill>
+                  <a:srgbClr val="67E1C5"/>
+                </a:solidFill>
+                <a:latin typeface="Segoe UI"/>
+              </a:rPr>
+              <a:t>Disciplined sim → noise-model → real metal. Tuned kernel held on average across IBM, IQM, VTT; robust config: near-zero drift on all three.</a:t>
+            </a:r>
+          </a:p>
+        </p:txBody>
+      </p:sp>
+    </p:spTree>
+  </p:cSld>
+  <p:clrMapOvr>
+    <a:masterClrMapping/>
+  </p:clrMapOvr>
+</p:sld>
+</file>
+
+<file path=ppt/slides/slide7.xml><?xml version="1.0" encoding="utf-8"?>
+<p:sld xmlns:a="http://schemas.openxmlformats.org/drawingml/2006/main" xmlns:p="http://schemas.openxmlformats.org/presentationml/2006/main" xmlns:r="http://schemas.openxmlformats.org/officeDocument/2006/relationships">
+  <p:cSld>
+    <p:spTree>
+      <p:nvGrpSpPr>
+        <p:cNvPr id="1" name=""/>
+        <p:cNvGrpSpPr/>
+        <p:nvPr/>
+      </p:nvGrpSpPr>
+      <p:grpSpPr/>
+      <p:sp>
+        <p:nvSpPr>
+          <p:cNvPr id="2" name="Rectangle 1"/>
+          <p:cNvSpPr/>
+          <p:nvPr/>
+        </p:nvSpPr>
+        <p:spPr>
+          <a:xfrm>
+            <a:off x="0" y="0"/>
+            <a:ext cx="12191695" cy="6858000"/>
+          </a:xfrm>
+          <a:prstGeom prst="rect">
+            <a:avLst/>
+          </a:prstGeom>
+          <a:solidFill>
+            <a:srgbClr val="102B32"/>
+          </a:solidFill>
+          <a:ln>
+            <a:noFill/>
+          </a:ln>
+          <a:effectLst/>
+        </p:spPr>
+        <p:style>
+          <a:lnRef idx="1">
+            <a:schemeClr val="accent1"/>
+          </a:lnRef>
+          <a:fillRef idx="3">
+            <a:schemeClr val="accent1"/>
+          </a:fillRef>
+          <a:effectRef idx="2">
+            <a:schemeClr val="accent1"/>
+          </a:effectRef>
+          <a:fontRef idx="minor">
+            <a:schemeClr val="lt1"/>
+          </a:fontRef>
+        </p:style>
+        <p:txBody>
+          <a:bodyPr rtlCol="0" anchor="ctr"/>
+          <a:lstStyle/>
+          <a:p>
+            <a:pPr algn="ctr"/>
+          </a:p>
+        </p:txBody>
+      </p:sp>
+      <p:sp>
+        <p:nvSpPr>
+          <p:cNvPr id="3" name="Rectangle 2"/>
+          <p:cNvSpPr/>
+          <p:nvPr/>
+        </p:nvSpPr>
+        <p:spPr>
+          <a:xfrm>
+            <a:off x="640080" y="475488"/>
+            <a:ext cx="1280160" cy="63500"/>
+          </a:xfrm>
+          <a:prstGeom prst="rect">
+            <a:avLst/>
+          </a:prstGeom>
+          <a:solidFill>
+            <a:srgbClr val="2EC4B6"/>
+          </a:solidFill>
+          <a:ln>
+            <a:noFill/>
+          </a:ln>
+          <a:effectLst/>
+        </p:spPr>
+        <p:style>
+          <a:lnRef idx="1">
+            <a:schemeClr val="accent1"/>
+          </a:lnRef>
+          <a:fillRef idx="3">
+            <a:schemeClr val="accent1"/>
+          </a:fillRef>
+          <a:effectRef idx="2">
+            <a:schemeClr val="accent1"/>
+          </a:effectRef>
+          <a:fontRef idx="minor">
+            <a:schemeClr val="lt1"/>
+          </a:fontRef>
+        </p:style>
+        <p:txBody>
+          <a:bodyPr rtlCol="0" anchor="ctr"/>
+          <a:lstStyle/>
+          <a:p>
+            <a:pPr algn="ctr"/>
+          </a:p>
+        </p:txBody>
+      </p:sp>
+      <p:sp>
+        <p:nvSpPr>
+          <p:cNvPr id="4" name="TextBox 3"/>
+          <p:cNvSpPr txBox="1"/>
+          <p:nvPr/>
+        </p:nvSpPr>
+        <p:spPr>
+          <a:xfrm>
+            <a:off x="640080" y="621792"/>
+            <a:ext cx="10972800" cy="822960"/>
+          </a:xfrm>
+          <a:prstGeom prst="rect">
+            <a:avLst/>
+          </a:prstGeom>
+          <a:noFill/>
+        </p:spPr>
+        <p:txBody>
+          <a:bodyPr wrap="square" anchor="t">
+            <a:spAutoFit/>
+          </a:bodyPr>
+          <a:lstStyle/>
+          <a:p>
+            <a:pPr algn="l">
+              <a:spcAft>
+                <a:spcPts val="800"/>
+              </a:spcAft>
+            </a:pPr>
+            <a:r>
+              <a:rPr sz="3200" b="1" i="0">
                 <a:solidFill>
                   <a:srgbClr val="FFFFFF"/>
                 </a:solidFill>
@@ -5748,8 +6066,8 @@
         </p:blipFill>
         <p:spPr>
           <a:xfrm>
-            <a:off x="1554480" y="1554480"/>
-            <a:ext cx="9144000" cy="6332220"/>
+            <a:off x="2825396" y="1463040"/>
+            <a:ext cx="6602166" cy="4572000"/>
           </a:xfrm>
           <a:prstGeom prst="rect">
             <a:avLst/>
@@ -5764,7 +6082,7 @@
         </p:nvSpPr>
         <p:spPr>
           <a:xfrm>
-            <a:off x="640080" y="6309360"/>
+            <a:off x="640080" y="6263640"/>
             <a:ext cx="10972800" cy="457200"/>
           </a:xfrm>
           <a:prstGeom prst="rect">
@@ -5803,7 +6121,7 @@
 </p:sld>
 </file>
 
-<file path=ppt/slides/slide7.xml><?xml version="1.0" encoding="utf-8"?>
+<file path=ppt/slides/slide8.xml><?xml version="1.0" encoding="utf-8"?>
 <p:sld xmlns:a="http://schemas.openxmlformats.org/drawingml/2006/main" xmlns:p="http://schemas.openxmlformats.org/presentationml/2006/main" xmlns:r="http://schemas.openxmlformats.org/officeDocument/2006/relationships">
   <p:cSld>
     <p:spTree>

</xml_diff>

<commit_message>
Honest hardware reframe: drop 512-shot stopgap, show 3 full-shot runs
- Full 1024-shot IBM run (0.395) exposed the tuned config's hardware instability:
  near-degenerate SVM amplifies tiny readout noise into huge PR-AUC swings
  (0.183/0.265/0.395 scatter around 0.231 sim; IBM above the noiseless sim = noise)
- Reframed to: robust c=1 is the reliable hardware validation; tuned c=0.1 is a
  fragility finding, not a win. Added reliability chart (make_reliability_chart.py)
- Updated RESULTS, deck slide 6, talk beat 6 + guardrails; dropped 512-shot everywhere
- Demo hardware panel + GIF re-recorded to the 3 full-shot runs with honest note
- Added Q&A: "does nothing for business", "it's theoretical", "why a QPU",
  "is it even quantum", "features are the ceiling", "isn't big IBM just noisier"
- Fixed slide 6 title/chart overlap

Co-Authored-By: Claude Opus 4.8 <noreply@anthropic.com>
</commit_message>
<xml_diff>
--- a/QSIEVE_pitch.pptx
+++ b/QSIEVE_pitch.pptx
@@ -859,7 +859,7 @@
           <a:lstStyle/>
           <a:p>
             <a:r>
-              <a:t>[2:06-2:38 HARDWARE] A simulator tie is cheap. 3 real QPUs - IQM Garnet, IBM, VTT Q50 - sim, then noise model, then chip. Quiet 6-qubit config: Garnet &amp; IBM reproduce the sim exactly (0.111-&gt;0.111), Q50 moves one point. Tuned: the 3 chips average back onto the sim, 0.22 vs 0.23. Held on average, 3 vendors. Runs on real metal today.</a:t>
+              <a:t>[2:06-2:38 HARDWARE] A simulator tie is cheap. 3 real QPUs - Garnet, IBM, Q50 - sim, noise model, then chip. The ROBUST 6-qubit config held rock-solid: Garnet &amp; IBM reproduce the sim exactly (0.111-&gt;0.111), Q50 off one point, near-zero drift. That's the result we trust. Honest part: the aggressive TUNED kernel bounced 0.18 to 0.40 across runs - one IBM run even above the noiseless sim, impossible for real signal. Cause: the tuned model is near-degenerate, amplifying tiny noise into huge swings. Tuning buys sim score, costs on-device stability. The robust config is the one that runs.</a:t>
             </a:r>
           </a:p>
         </p:txBody>
@@ -5729,13 +5729,13 @@
               </a:spcAft>
             </a:pPr>
             <a:r>
-              <a:rPr sz="3200" b="1" i="0">
+              <a:rPr sz="2800" b="1" i="0">
                 <a:solidFill>
                   <a:srgbClr val="FFFFFF"/>
                 </a:solidFill>
                 <a:latin typeface="Segoe UI"/>
               </a:rPr>
-              <a:t>Then we proved it on three real quantum computers</a:t>
+              <a:t>On three real quantum computers</a:t>
             </a:r>
           </a:p>
         </p:txBody>
@@ -5781,7 +5781,7 @@
       </p:sp>
       <p:pic>
         <p:nvPicPr>
-          <p:cNvPr id="6" name="Picture 5" descr="03_hardware_tuned.png"/>
+          <p:cNvPr id="6" name="Picture 5" descr="06_hardware_reliability.png"/>
           <p:cNvPicPr>
             <a:picLocks noChangeAspect="1"/>
           </p:cNvPicPr>
@@ -5795,48 +5795,24 @@
         </p:blipFill>
         <p:spPr>
           <a:xfrm>
-            <a:off x="457200" y="2053256"/>
-            <a:ext cx="5577840" cy="2842927"/>
+            <a:off x="2064911" y="1600200"/>
+            <a:ext cx="8123136" cy="4114800"/>
           </a:xfrm>
           <a:prstGeom prst="rect">
             <a:avLst/>
           </a:prstGeom>
         </p:spPr>
       </p:pic>
-      <p:pic>
-        <p:nvPicPr>
-          <p:cNvPr id="7" name="Picture 6" descr="04_hardware_robust.png"/>
-          <p:cNvPicPr>
-            <a:picLocks noChangeAspect="1"/>
-          </p:cNvPicPr>
-          <p:nvPr/>
-        </p:nvPicPr>
-        <p:blipFill>
-          <a:blip r:embed="rId3"/>
-          <a:stretch>
-            <a:fillRect/>
-          </a:stretch>
-        </p:blipFill>
-        <p:spPr>
-          <a:xfrm>
-            <a:off x="6153912" y="1987608"/>
-            <a:ext cx="5577840" cy="2974223"/>
-          </a:xfrm>
-          <a:prstGeom prst="rect">
-            <a:avLst/>
-          </a:prstGeom>
-        </p:spPr>
-      </p:pic>
-      <p:sp>
-        <p:nvSpPr>
-          <p:cNvPr id="8" name="TextBox 7"/>
+      <p:sp>
+        <p:nvSpPr>
+          <p:cNvPr id="7" name="TextBox 6"/>
           <p:cNvSpPr txBox="1"/>
           <p:nvPr/>
         </p:nvSpPr>
         <p:spPr>
           <a:xfrm>
-            <a:off x="640080" y="5715000"/>
-            <a:ext cx="10972800" cy="914400"/>
+            <a:off x="640080" y="5943600"/>
+            <a:ext cx="10972800" cy="822960"/>
           </a:xfrm>
           <a:prstGeom prst="rect">
             <a:avLst/>
@@ -5855,13 +5831,13 @@
               </a:spcAft>
             </a:pPr>
             <a:r>
-              <a:rPr sz="1600" b="1" i="0">
+              <a:rPr sz="1500" b="1" i="0">
                 <a:solidFill>
                   <a:srgbClr val="67E1C5"/>
                 </a:solidFill>
                 <a:latin typeface="Segoe UI"/>
               </a:rPr>
-              <a:t>Disciplined sim → noise-model → real metal. Tuned kernel held on average across IBM, IQM, VTT; robust config: near-zero drift on all three.</a:t>
+              <a:t>Disciplined sim → noise-model → real metal. The robust config reproduces the simulator on all three vendors (near-zero drift). The tuned config runs — but its score is noise-dominated. A finding, honestly reported.</a:t>
             </a:r>
           </a:p>
         </p:txBody>
@@ -6066,8 +6042,8 @@
         </p:blipFill>
         <p:spPr>
           <a:xfrm>
-            <a:off x="2825396" y="1463040"/>
-            <a:ext cx="6602166" cy="4572000"/>
+            <a:off x="3078479" y="1463040"/>
+            <a:ext cx="6096000" cy="4572000"/>
           </a:xfrm>
           <a:prstGeom prst="rect">
             <a:avLst/>

</xml_diff>

<commit_message>
Scope-humility + fix account-week wording
- State the narrow scope explicitly (talk beat 2 + Q&A + deck slide 2): not solving
  money-laundering or clearing the whole queue, just auto-clearing confidently-innocent
  flagged windows to remove analyst busywork
- Fix deck slide 2: "~388k accounts/year" -> "~388k flagged account-week windows"
  (windows are per ISO-week, not accounts per year)

Co-Authored-By: Claude Opus 4.8 <noreply@anthropic.com>
</commit_message>
<xml_diff>
--- a/QSIEVE_pitch.pptx
+++ b/QSIEVE_pitch.pptx
@@ -4523,7 +4523,7 @@
                 </a:solidFill>
                 <a:latin typeface="Segoe UI"/>
               </a:rPr>
-              <a:t>Banks flag ~388k accounts/year.</a:t>
+              <a:t>~388k flagged account-week windows.</a:t>
             </a:r>
           </a:p>
           <a:p>
@@ -4539,7 +4539,7 @@
                 </a:solidFill>
                 <a:latin typeface="Segoe UI"/>
               </a:rPr>
-              <a:t>96% are innocent, cleared by hand.</a:t>
+              <a:t>96% innocent, cleared by hand.</a:t>
             </a:r>
           </a:p>
         </p:txBody>
@@ -4722,6 +4722,45 @@
                 <a:latin typeface="Segoe UI"/>
               </a:rPr>
               <a:t>two accounts?” — that's our question.</a:t>
+            </a:r>
+          </a:p>
+        </p:txBody>
+      </p:sp>
+      <p:sp>
+        <p:nvSpPr>
+          <p:cNvPr id="10" name="TextBox 9"/>
+          <p:cNvSpPr txBox="1"/>
+          <p:nvPr/>
+        </p:nvSpPr>
+        <p:spPr>
+          <a:xfrm>
+            <a:off x="640080" y="5943600"/>
+            <a:ext cx="10972800" cy="640080"/>
+          </a:xfrm>
+          <a:prstGeom prst="rect">
+            <a:avLst/>
+          </a:prstGeom>
+          <a:noFill/>
+        </p:spPr>
+        <p:txBody>
+          <a:bodyPr wrap="square" anchor="t">
+            <a:spAutoFit/>
+          </a:bodyPr>
+          <a:lstStyle/>
+          <a:p>
+            <a:pPr algn="l">
+              <a:spcAft>
+                <a:spcPts val="800"/>
+              </a:spcAft>
+            </a:pPr>
+            <a:r>
+              <a:rPr sz="1500" b="1" i="0">
+                <a:solidFill>
+                  <a:srgbClr val="E6B74D"/>
+                </a:solidFill>
+                <a:latin typeface="Segoe UI"/>
+              </a:rPr>
+              <a:t>Scope, honestly: not solving money-laundering, not clearing the whole queue — just auto-clearing the confidently-innocent windows to give analysts their time back.</a:t>
             </a:r>
           </a:p>
         </p:txBody>

</xml_diff>

<commit_message>
Align slides with talk + two shore-ups; fix overclaims
- Slide 2: 96% -> ~99% innocent (4,084 suspicious of 388,538)
- Slide 5: "level with the tree" -> honest "a tie, 0.18 vs 0.17, within noise";
  "no trial-and-error" -> "we swept, then DERIVED it" (we did search; the formula
  lands on the measured peak so the next run needn't)
- Slide 6: "reproduces on all three" -> Garnet/IBM exact, Q50 off one point (0.100)
- Slide 8: drop "the first"; add honest limits (safe-clear 0%, tree faster) +
  Impact line (tells a bank WHEN quantum is worth investing in - timing worth millions)
- Innovativeness shore-up: "the innovation is the method" on slide 5 + talk

Co-Authored-By: Claude Opus 4.8 <noreply@anthropic.com>
</commit_message>
<xml_diff>
--- a/QSIEVE_pitch.pptx
+++ b/QSIEVE_pitch.pptx
@@ -789,7 +789,7 @@
           <a:lstStyle/>
           <a:p>
             <a:r>
-              <a:t>[1:34-2:06 BANDWIDTH] Found it: the bandwidth was wrong, the kernel blind. Shrink the angles to ~a tenth: 0.12 -&gt; 0.18, level with the tree (0.17). Error bars overlap = a TIE, not a win - say it plainly. And we DERIVED the scale, 1/sqrt(n*d) = 0.083, hitting the measured peak. No trial-and-error.</a:t>
+              <a:t>[1:34-2:06 BANDWIDTH] Found it: the bandwidth was wrong, the kernel blind. Shrink the angles to ~a tenth: 0.12 -&gt; 0.18, level with the tree (0.17). Error bars overlap = a TIE, not a win - say it plainly. We SWEPT to find it, then showed 1/sqrt(n*d) = 0.083 predicts the peak - so the next run needs no sweep. The innovation is the method: derive, don't guess.</a:t>
             </a:r>
           </a:p>
         </p:txBody>
@@ -4539,7 +4539,7 @@
                 </a:solidFill>
                 <a:latin typeface="Segoe UI"/>
               </a:rPr>
-              <a:t>96% innocent, cleared by hand.</a:t>
+              <a:t>~99% innocent, cleared by hand.</a:t>
             </a:r>
           </a:p>
         </p:txBody>
@@ -5597,7 +5597,7 @@
                 </a:solidFill>
                 <a:latin typeface="Segoe UI"/>
               </a:rPr>
-              <a:t>•  Level with the tuned classical tree.</a:t>
+              <a:t>•  A tie: 0.18 vs 0.17, within noise — not a win.</a:t>
             </a:r>
           </a:p>
           <a:p>
@@ -5613,7 +5613,7 @@
                 </a:solidFill>
                 <a:latin typeface="Segoe UI"/>
               </a:rPr>
-              <a:t>•  No trial-and-error — derived: c = 1/√(n·d) = 0.083,</a:t>
+              <a:t>•  We swept to find it — then derived it: c = 1/√(n·d) = 0.083 predicts the peak.</a:t>
             </a:r>
           </a:p>
           <a:p>
@@ -5629,7 +5629,7 @@
                 </a:solidFill>
                 <a:latin typeface="Segoe UI"/>
               </a:rPr>
-              <a:t>•  landing exactly on the measured peak.</a:t>
+              <a:t>•  The innovation is the method: derive the setting, don't guess it.</a:t>
             </a:r>
           </a:p>
         </p:txBody>
@@ -5876,7 +5876,7 @@
                 </a:solidFill>
                 <a:latin typeface="Segoe UI"/>
               </a:rPr>
-              <a:t>Disciplined sim → noise-model → real metal. The robust config reproduces the simulator on all three vendors (near-zero drift). The tuned config runs — but its score is noise-dominated. A finding, honestly reported.</a:t>
+              <a:t>Disciplined sim → noise-model → real metal. Robust config: Garnet and IBM exact (0.111→0.111), Q50 off one point (0.100), near-zero drift. The tuned config runs — but its score is noise-dominated. A finding, honestly reported.</a:t>
             </a:r>
           </a:p>
         </p:txBody>
@@ -6269,17 +6269,17 @@
           <a:p>
             <a:pPr algn="l">
               <a:spcAft>
-                <a:spcPts val="1400"/>
+                <a:spcPts val="1200"/>
               </a:spcAft>
             </a:pPr>
             <a:r>
-              <a:rPr sz="2200" b="0" i="0">
+              <a:rPr sz="2000" b="0" i="0">
                 <a:solidFill>
                   <a:srgbClr val="ADC5C7"/>
                 </a:solidFill>
                 <a:latin typeface="Segoe UI"/>
               </a:rPr>
-              <a:t>and anyone who does is selling you something.</a:t>
+              <a:t>and anyone who does is selling you something. Safe-clear is 0% today; the tree is faster.</a:t>
             </a:r>
           </a:p>
           <a:p>
@@ -6289,29 +6289,45 @@
               </a:spcAft>
             </a:pPr>
             <a:r>
-              <a:rPr sz="2200" b="0" i="0">
+              <a:rPr sz="2100" b="0" i="0">
                 <a:solidFill>
                   <a:srgbClr val="FFFFFF"/>
                 </a:solidFill>
                 <a:latin typeface="Segoe UI"/>
               </a:rPr>
-              <a:t>What we can give you: the first rigorous, hardware-validated map of exactly</a:t>
+              <a:t>What we give you: an honest, hardware-validated map of exactly how close</a:t>
             </a:r>
           </a:p>
           <a:p>
             <a:pPr algn="l">
               <a:spcAft>
-                <a:spcPts val="1600"/>
+                <a:spcPts val="1200"/>
               </a:spcAft>
             </a:pPr>
             <a:r>
-              <a:rPr sz="2200" b="0" i="0">
+              <a:rPr sz="2100" b="0" i="0">
                 <a:solidFill>
                   <a:srgbClr val="FFFFFF"/>
                 </a:solidFill>
                 <a:latin typeface="Segoe UI"/>
               </a:rPr>
-              <a:t>how close it gets, why it was stuck, and how to fix it — analytically.</a:t>
+              <a:t>it gets, why it was stuck, and how to fix it — analytically.</a:t>
+            </a:r>
+          </a:p>
+          <a:p>
+            <a:pPr algn="l">
+              <a:spcAft>
+                <a:spcPts val="1400"/>
+              </a:spcAft>
+            </a:pPr>
+            <a:r>
+              <a:rPr sz="1600" b="0" i="0">
+                <a:solidFill>
+                  <a:srgbClr val="E6B74D"/>
+                </a:solidFill>
+                <a:latin typeface="Segoe UI"/>
+              </a:rPr>
+              <a:t>It tells a bank WHEN quantum is worth investing in for compliance — a timing call worth millions.</a:t>
             </a:r>
           </a:p>
           <a:p>
@@ -6321,7 +6337,7 @@
               </a:spcAft>
             </a:pPr>
             <a:r>
-              <a:rPr sz="2600" b="1" i="0">
+              <a:rPr sz="2500" b="1" i="0">
                 <a:solidFill>
                   <a:srgbClr val="67E1C5"/>
                 </a:solidFill>

</xml_diff>

<commit_message>
Deck: explain the random floor on slide 4 (0.09 = ~1-in-10 prevalence)
Co-Authored-By: Claude Opus 4.8 <noreply@anthropic.com>
</commit_message>
<xml_diff>
--- a/QSIEVE_pitch.pptx
+++ b/QSIEVE_pitch.pptx
@@ -5270,7 +5270,7 @@
                 </a:solidFill>
                 <a:latin typeface="Segoe UI"/>
               </a:rPr>
-              <a:t>•  XGBoost 0.19 beat quantum 0.125.</a:t>
+              <a:t>•  Floor 0.09 = random guessing: ~1 in 10 windows is truly suspicious.</a:t>
             </a:r>
           </a:p>
           <a:p>
@@ -5286,7 +5286,7 @@
                 </a:solidFill>
                 <a:latin typeface="Segoe UI"/>
               </a:rPr>
-              <a:t>•  We could have spun it. We asked WHY —</a:t>
+              <a:t>•  XGBoost 0.19, quantum 0.125 — above the floor is real skill.</a:t>
             </a:r>
           </a:p>
           <a:p>
@@ -5302,7 +5302,7 @@
                 </a:solidFill>
                 <a:latin typeface="Segoe UI"/>
               </a:rPr>
-              <a:t>•  and tested 4 encodings, 8 scalings, training, a hybrid.</a:t>
+              <a:t>•  We asked WHY, and tested 4 encodings, 8 scalings, training, a hybrid.</a:t>
             </a:r>
           </a:p>
           <a:p>

</xml_diff>

<commit_message>
Deck: slide 3 -> the 0.093 floor derivation; slides 4/5 updated to match
Co-Authored-By: Claude Opus 4.8 <noreply@anthropic.com>
</commit_message>
<xml_diff>
--- a/QSIEVE_pitch.pptx
+++ b/QSIEVE_pitch.pptx
@@ -649,7 +649,7 @@
           <a:lstStyle/>
           <a:p>
             <a:r>
-              <a:t>[0:52-1:14 MATH] 30 seconds on how it works. Each account becomes a quantum state; the kernel is how much two states overlap (identical = 1, opposite = 0). The catch, and it's our whole result: rotate too far and every account spreads to opposite corners, all look equally different - the kernel goes blind. How far you rotate is one number: the bandwidth. Hold that word.</a:t>
+              <a:t>[FLOOR] Before any score, one number. Of the 388,000 flagged windows, about 1% are actually suspicious - the real queue. The table we SCORE keeps all 4,084 suspicious and caps the innocent at 40,000, so it is 9.3% suspicious. A model ranking at random scores that prevalence: 0.093. That is the floor. Every number after this starts there.</a:t>
             </a:r>
           </a:p>
         </p:txBody>
@@ -4905,7 +4905,7 @@
                 </a:solidFill>
                 <a:latin typeface="Segoe UI"/>
               </a:rPr>
-              <a:t>How the kernel works — and the one knob that matters</a:t>
+              <a:t>Where every number starts: the 0.093 floor</a:t>
             </a:r>
           </a:p>
         </p:txBody>
@@ -4944,45 +4944,21 @@
                 </a:solidFill>
                 <a:latin typeface="Segoe UI"/>
               </a:rPr>
-              <a:t>THE MECHANISM</a:t>
-            </a:r>
-          </a:p>
-        </p:txBody>
-      </p:sp>
-      <p:pic>
-        <p:nvPicPr>
-          <p:cNvPr id="6" name="Picture 5" descr="05_kernel_concept.png"/>
-          <p:cNvPicPr>
-            <a:picLocks noChangeAspect="1"/>
-          </p:cNvPicPr>
-          <p:nvPr/>
-        </p:nvPicPr>
-        <p:blipFill>
-          <a:blip r:embed="rId2"/>
-          <a:stretch>
-            <a:fillRect/>
-          </a:stretch>
-        </p:blipFill>
-        <p:spPr>
-          <a:xfrm>
-            <a:off x="1981016" y="1371600"/>
-            <a:ext cx="8290927" cy="4480560"/>
-          </a:xfrm>
-          <a:prstGeom prst="rect">
-            <a:avLst/>
-          </a:prstGeom>
-        </p:spPr>
-      </p:pic>
-      <p:sp>
-        <p:nvSpPr>
-          <p:cNvPr id="7" name="TextBox 6"/>
+              <a:t>METHODOLOGY</a:t>
+            </a:r>
+          </a:p>
+        </p:txBody>
+      </p:sp>
+      <p:sp>
+        <p:nvSpPr>
+          <p:cNvPr id="6" name="TextBox 5"/>
           <p:cNvSpPr txBox="1"/>
           <p:nvPr/>
         </p:nvSpPr>
         <p:spPr>
           <a:xfrm>
-            <a:off x="640080" y="5943600"/>
-            <a:ext cx="10972800" cy="731520"/>
+            <a:off x="731520" y="1783080"/>
+            <a:ext cx="10698480" cy="2743200"/>
           </a:xfrm>
           <a:prstGeom prst="rect">
             <a:avLst/>
@@ -4994,6 +4970,38 @@
             <a:spAutoFit/>
           </a:bodyPr>
           <a:lstStyle/>
+          <a:p>
+            <a:pPr algn="l">
+              <a:spcAft>
+                <a:spcPts val="1800"/>
+              </a:spcAft>
+            </a:pPr>
+            <a:r>
+              <a:rPr sz="2300" b="0" i="0">
+                <a:solidFill>
+                  <a:srgbClr val="FFFFFF"/>
+                </a:solidFill>
+                <a:latin typeface="Segoe UI"/>
+              </a:rPr>
+              <a:t>•  388,000 flagged windows — about 1% are truly suspicious (the real queue).</a:t>
+            </a:r>
+          </a:p>
+          <a:p>
+            <a:pPr algn="l">
+              <a:spcAft>
+                <a:spcPts val="1800"/>
+              </a:spcAft>
+            </a:pPr>
+            <a:r>
+              <a:rPr sz="2300" b="0" i="0">
+                <a:solidFill>
+                  <a:srgbClr val="FFFFFF"/>
+                </a:solidFill>
+                <a:latin typeface="Segoe UI"/>
+              </a:rPr>
+              <a:t>•  The table we score keeps all 4,084 suspicious + 40,000 innocent → 9.3% suspicious.</a:t>
+            </a:r>
+          </a:p>
           <a:p>
             <a:pPr algn="l">
               <a:spcAft>
@@ -5001,13 +5009,88 @@
               </a:spcAft>
             </a:pPr>
             <a:r>
-              <a:rPr sz="1600" b="1" i="0">
+              <a:rPr sz="2300" b="1" i="0">
                 <a:solidFill>
                   <a:srgbClr val="67E1C5"/>
                 </a:solidFill>
                 <a:latin typeface="Segoe UI"/>
               </a:rPr>
-              <a:t>Similarity = overlap of two account-states.  “Bandwidth” = how far we rotate the data — and it decides whether the kernel can see at all.  Hold that thought.</a:t>
+              <a:t>•  A model ranking at random scores that share — PR-AUC = 0.093.</a:t>
+            </a:r>
+          </a:p>
+        </p:txBody>
+      </p:sp>
+      <p:sp>
+        <p:nvSpPr>
+          <p:cNvPr id="7" name="Rectangle 6"/>
+          <p:cNvSpPr/>
+          <p:nvPr/>
+        </p:nvSpPr>
+        <p:spPr>
+          <a:xfrm>
+            <a:off x="3566160" y="4892040"/>
+            <a:ext cx="5029200" cy="1371600"/>
+          </a:xfrm>
+          <a:prstGeom prst="rect">
+            <a:avLst/>
+          </a:prstGeom>
+          <a:solidFill>
+            <a:srgbClr val="173B42"/>
+          </a:solidFill>
+          <a:ln w="25400">
+            <a:solidFill>
+              <a:srgbClr val="E6B74D"/>
+            </a:solidFill>
+          </a:ln>
+          <a:effectLst/>
+        </p:spPr>
+        <p:style>
+          <a:lnRef idx="1">
+            <a:schemeClr val="accent1"/>
+          </a:lnRef>
+          <a:fillRef idx="3">
+            <a:schemeClr val="accent1"/>
+          </a:fillRef>
+          <a:effectRef idx="2">
+            <a:schemeClr val="accent1"/>
+          </a:effectRef>
+          <a:fontRef idx="minor">
+            <a:schemeClr val="lt1"/>
+          </a:fontRef>
+        </p:style>
+        <p:txBody>
+          <a:bodyPr rtlCol="0" anchor="ctr" wrap="square"/>
+          <a:lstStyle/>
+          <a:p>
+            <a:pPr algn="ctr">
+              <a:spcAft>
+                <a:spcPts val="200"/>
+              </a:spcAft>
+            </a:pPr>
+            <a:r>
+              <a:rPr sz="2600" b="1" i="0">
+                <a:solidFill>
+                  <a:srgbClr val="E6B74D"/>
+                </a:solidFill>
+                <a:latin typeface="Segoe UI"/>
+              </a:rPr>
+              <a:t>0.093 = the floor</a:t>
+            </a:r>
+          </a:p>
+          <a:p>
+            <a:pPr algn="ctr">
+              <a:spcAft>
+                <a:spcPts val="800"/>
+              </a:spcAft>
+            </a:pPr>
+            <a:r>
+              <a:rPr sz="1500" b="0" i="0">
+                <a:solidFill>
+                  <a:srgbClr val="FFFFFF"/>
+                </a:solidFill>
+                <a:latin typeface="Segoe UI"/>
+              </a:rPr>
+              <a:t>every number after this starts here</a:t>
             </a:r>
           </a:p>
         </p:txBody>
@@ -5254,7 +5337,7 @@
                 </a:solidFill>
                 <a:latin typeface="Segoe UI"/>
               </a:rPr>
-              <a:t>Tuned classical vs quantum, identical data.</a:t>
+              <a:t>Tuned classical vs quantum, identical data — both scored against that 0.093 floor.</a:t>
             </a:r>
           </a:p>
           <a:p>
@@ -5270,7 +5353,7 @@
                 </a:solidFill>
                 <a:latin typeface="Segoe UI"/>
               </a:rPr>
-              <a:t>•  Floor 0.09 = random guessing: ~1 in 10 windows is truly suspicious.</a:t>
+              <a:t>•  XGBoost 0.19, quantum 0.125 — both above the floor, so both are real signal.</a:t>
             </a:r>
           </a:p>
           <a:p>
@@ -5286,23 +5369,7 @@
                 </a:solidFill>
                 <a:latin typeface="Segoe UI"/>
               </a:rPr>
-              <a:t>•  XGBoost 0.19, quantum 0.125 — above the floor is real skill.</a:t>
-            </a:r>
-          </a:p>
-          <a:p>
-            <a:pPr algn="l">
-              <a:spcAft>
-                <a:spcPts val="800"/>
-              </a:spcAft>
-            </a:pPr>
-            <a:r>
-              <a:rPr sz="1500" b="0" i="0">
-                <a:solidFill>
-                  <a:srgbClr val="ADC5C7"/>
-                </a:solidFill>
-                <a:latin typeface="Segoe UI"/>
-              </a:rPr>
-              <a:t>•  We asked WHY, and tested 4 encodings, 8 scalings, training, a hybrid.</a:t>
+              <a:t>•  But the tree wins. We asked WHY: 4 encodings, 8 scalings, training, a hybrid.</a:t>
             </a:r>
           </a:p>
           <a:p>
@@ -5559,13 +5626,13 @@
               </a:spcAft>
             </a:pPr>
             <a:r>
-              <a:rPr sz="1700" b="1" i="0">
+              <a:rPr sz="1600" b="1" i="0">
                 <a:solidFill>
                   <a:srgbClr val="FFFFFF"/>
                 </a:solidFill>
                 <a:latin typeface="Segoe UI"/>
               </a:rPr>
-              <a:t>Wrong scale → the kernel “concentrated”, lost signal.</a:t>
+              <a:t>Bandwidth = how far features rotate. At the full range every pair looks equally different — the kernel goes blind.</a:t>
             </a:r>
           </a:p>
           <a:p>

</xml_diff>

<commit_message>
Slide 1: remove the prize category line; single consolidated deck
Co-Authored-By: Claude Opus 4.8 <noreply@anthropic.com>
</commit_message>
<xml_diff>
--- a/QSIEVE_pitch.pptx
+++ b/QSIEVE_pitch.pptx
@@ -929,7 +929,7 @@
           <a:lstStyle/>
           <a:p>
             <a:r>
-              <a:t>[2:38-2:52 DEMO] All live: the ranked queue, the auto-clear, an audit line per decision, and the evaluation page with the three-machine table. Real data, real results.</a:t>
+              <a:t>[2:38-2:52 DEMO] All live: the ranked queue, the auto-clear, an audit line per decision, and the three-machine table. NARRATE if the auto-clear banner plays: that 27/425 at 6.3% is the demo's ILLUSTRATIVE 0.20 cutoff - the SAFE bar (&lt;=1% error) clears NOTHING. The sidebar '12-qubit' is the simulator model; hardware runs 6 qubits.</a:t>
             </a:r>
           </a:p>
         </p:txBody>
@@ -4209,7 +4209,7 @@
                 </a:solidFill>
                 <a:latin typeface="Segoe UI"/>
               </a:rPr>
-              <a:t>Team Q-SIEVE   ·   Quantum × Finance Hackathon, Hanken   ·   Best Technical Implementation</a:t>
+              <a:t>Team Q-SIEVE   ·   Quantum × Finance Hackathon, Hanken</a:t>
             </a:r>
           </a:p>
         </p:txBody>
@@ -5590,8 +5590,8 @@
         </p:blipFill>
         <p:spPr>
           <a:xfrm>
-            <a:off x="640080" y="1588343"/>
-            <a:ext cx="7498079" cy="4138511"/>
+            <a:off x="640080" y="1658112"/>
+            <a:ext cx="7498079" cy="3998975"/>
           </a:xfrm>
           <a:prstGeom prst="rect">
             <a:avLst/>
@@ -5901,8 +5901,8 @@
         </p:blipFill>
         <p:spPr>
           <a:xfrm>
-            <a:off x="2064911" y="1600200"/>
-            <a:ext cx="8123136" cy="4114800"/>
+            <a:off x="2046280" y="1600200"/>
+            <a:ext cx="8160398" cy="4114800"/>
           </a:xfrm>
           <a:prstGeom prst="rect">
             <a:avLst/>

</xml_diff>

<commit_message>
Deck: embed fixed bandwidth chart (readable geometric-rule label + encoding-labeled lines)
Co-Authored-By: Claude Opus 4.8 <noreply@anthropic.com>
</commit_message>
<xml_diff>
--- a/QSIEVE_pitch.pptx
+++ b/QSIEVE_pitch.pptx
@@ -5590,8 +5590,8 @@
         </p:blipFill>
         <p:spPr>
           <a:xfrm>
-            <a:off x="640080" y="1658112"/>
-            <a:ext cx="7498079" cy="3998975"/>
+            <a:off x="640080" y="1634353"/>
+            <a:ext cx="7498079" cy="4046493"/>
           </a:xfrm>
           <a:prstGeom prst="rect">
             <a:avLst/>

</xml_diff>

<commit_message>
Put the live analyst demo on a public page and link it from slide 7.
Co-authored-by: Cursor <cursoragent@cursor.com>
</commit_message>
<xml_diff>
--- a/QSIEVE_pitch.pptx
+++ b/QSIEVE_pitch.pptx
@@ -929,7 +929,7 @@
           <a:lstStyle/>
           <a:p>
             <a:r>
-              <a:t>[2:38-2:52 DEMO] All live: the ranked queue, the auto-clear, an audit line per decision, and the three-machine table. NARRATE if the auto-clear banner plays: that 27/425 at 6.3% is the demo's ILLUSTRATIVE 0.20 cutoff - the SAFE bar (&lt;=1% error) clears NOTHING. The sidebar '12-qubit' is the simulator model; hardware runs 6 qubits.</a:t>
+              <a:t>[2:38-2:52 DEMO] All live: the ranked queue, the auto-clear, an audit line per decision, and the three-machine table. NARRATE if the auto-clear banner plays: that 27/425 at 6.3% is the demo's ILLUSTRATIVE 0.20 cutoff - the SAFE bar (&lt;=1% error) clears NOTHING. The sidebar '12-qubit' is the simulator model; hardware runs 6 qubits. Links on the slide: github.com/ELNAUL99/q-sieve and elnaul99.github.io/q-sieve.</a:t>
             </a:r>
           </a:p>
         </p:txBody>
@@ -6148,8 +6148,8 @@
         </p:blipFill>
         <p:spPr>
           <a:xfrm>
-            <a:off x="3078479" y="1463040"/>
-            <a:ext cx="6096000" cy="4572000"/>
+            <a:off x="3362514" y="1400000"/>
+            <a:ext cx="5466667" cy="4100000"/>
           </a:xfrm>
           <a:prstGeom prst="rect">
             <a:avLst/>
@@ -6164,8 +6164,8 @@
         </p:nvSpPr>
         <p:spPr>
           <a:xfrm>
-            <a:off x="640080" y="6263640"/>
-            <a:ext cx="10972800" cy="457200"/>
+            <a:off x="640080" y="6380000"/>
+            <a:ext cx="10972800" cy="420000"/>
           </a:xfrm>
           <a:prstGeom prst="rect">
             <a:avLst/>
@@ -6191,6 +6191,75 @@
                 <a:latin typeface="Segoe UI"/>
               </a:rPr>
               <a:t>Queue → auto-clear → benchmark → the 3-QPU panel → full audit trail. (Animates in slideshow.)</a:t>
+            </a:r>
+          </a:p>
+        </p:txBody>
+      </p:sp>
+      <p:sp>
+        <p:nvSpPr>
+          <p:cNvPr id="8" name="TextBox 7"/>
+          <p:cNvSpPr txBox="1"/>
+          <p:nvPr/>
+        </p:nvSpPr>
+        <p:spPr>
+          <a:xfrm>
+            <a:off x="640080" y="5580000"/>
+            <a:ext cx="10972800" cy="720000"/>
+          </a:xfrm>
+          <a:prstGeom prst="rect">
+            <a:avLst/>
+          </a:prstGeom>
+          <a:noFill/>
+        </p:spPr>
+        <p:txBody>
+          <a:bodyPr wrap="square" anchor="t"/>
+          <a:lstStyle/>
+          <a:p>
+            <a:pPr algn="l">
+              <a:spcAft>
+                <a:spcPts val="160"/>
+              </a:spcAft>
+            </a:pPr>
+            <a:r>
+              <a:rPr lang="en-US" sz="1600" b="1" dirty="0">
+                <a:solidFill>
+                  <a:srgbClr val="ADC5C7"/>
+                </a:solidFill>
+                <a:latin typeface="Segoe UI"/>
+              </a:rPr>
+              <a:t>Code   </a:t>
+            </a:r>
+            <a:r>
+              <a:rPr lang="en-US" sz="1600" b="1" u="sng" dirty="0">
+                <a:solidFill>
+                  <a:srgbClr val="67E1C5"/>
+                </a:solidFill>
+                <a:latin typeface="Segoe UI"/>
+                <a:hlinkClick r:id="rId4"/>
+              </a:rPr>
+              <a:t>github.com/ELNAUL99/q-sieve</a:t>
+            </a:r>
+          </a:p>
+          <a:p>
+            <a:pPr algn="l"/>
+            <a:r>
+              <a:rPr lang="en-US" sz="1600" b="1" dirty="0">
+                <a:solidFill>
+                  <a:srgbClr val="ADC5C7"/>
+                </a:solidFill>
+                <a:latin typeface="Segoe UI"/>
+              </a:rPr>
+              <a:t>Live demo   </a:t>
+            </a:r>
+            <a:r>
+              <a:rPr lang="en-US" sz="1600" b="1" u="sng" dirty="0">
+                <a:solidFill>
+                  <a:srgbClr val="67E1C5"/>
+                </a:solidFill>
+                <a:latin typeface="Segoe UI"/>
+                <a:hlinkClick r:id="rId5"/>
+              </a:rPr>
+              <a:t>elnaul99.github.io/q-sieve</a:t>
             </a:r>
           </a:p>
         </p:txBody>

</xml_diff>

<commit_message>
Align the public pages with the numbers the pitch defends.
Co-authored-by: Cursor <cursoragent@cursor.com>
</commit_message>
<xml_diff>
--- a/QSIEVE_pitch.pptx
+++ b/QSIEVE_pitch.pptx
@@ -789,7 +789,7 @@
           <a:lstStyle/>
           <a:p>
             <a:r>
-              <a:t>[1:34-2:06 BANDWIDTH] Found it: the bandwidth was wrong, the kernel blind. Shrink the angles to ~a tenth: 0.12 -&gt; 0.18, level with the tree (0.17). Error bars overlap = a TIE, not a win - say it plainly. We SWEPT to find it, then showed 1/sqrt(n*d) = 0.083 predicts the peak - so the next run needs no sweep. The innovation is the method: derive, don't guess.</a:t>
+              <a:t>[1:34-2:06 BANDWIDTH] Found it: the bandwidth was wrong, the kernel blind. Shrink the angles to ~a tenth: 0.12 -&gt; 0.18, level with the tree (0.17). Error bars overlap = a TIE, not a win - say it plainly. We SWEPT to find it, then showed 1/sqrt(n*d) = 0.083 lands in the peak. The rule is Shaydulin and Wild. We swept first, so the next choice does not need another sweep.</a:t>
             </a:r>
           </a:p>
         </p:txBody>
@@ -859,7 +859,7 @@
           <a:lstStyle/>
           <a:p>
             <a:r>
-              <a:t>[2:06-2:38 HARDWARE] A simulator tie is cheap. 3 real QPUs - Garnet, IBM, Q50 - sim, noise model, then chip. The ROBUST 6-qubit config held rock-solid: Garnet &amp; IBM reproduce the sim exactly (0.111-&gt;0.111), Q50 off one point, near-zero drift. That's the result we trust. Honest part: the aggressive TUNED kernel bounced 0.18 to 0.40 across runs - one IBM run even above the noiseless sim, impossible for real signal. Cause: the tuned model is near-degenerate, amplifying tiny noise into huge swings. Tuning buys sim score, costs on-device stability. The robust config is the one that runs.</a:t>
+              <a:t>[2:06-2:38 HARDWARE] A simulator tie is cheap. 3 real QPUs - Garnet, IBM, Q50 - sim, noise model, then chip. The ROBUST 6-qubit config held rock-solid: Garnet &amp; IBM reproduce the sim exactly (0.111-&gt;0.111), Q50 off one point, drift under 0.02. That's the result we trust. Honest part: the aggressive TUNED kernel bounced 0.18 to 0.40 across runs - one IBM run even above the noiseless sim, impossible for real signal. Cause: the tuned model is near-degenerate, amplifying tiny noise into huge swings. Tuning buys sim score, costs on-device stability. The robust config is the one that runs.</a:t>
             </a:r>
           </a:p>
         </p:txBody>

</xml_diff>